<commit_message>
docs(demo): 'Bring your agents, from any harness' on the loop slide and in the thesis beat
The harness list moves out of the Join card into one line under the loop: fully supported today — Claude Code, Codex, Cursor, OpenCode; musterd's own harness coming. nick's wording, 2026-09-30. §8 1:15 beat 110 words; total 817 (752 without delta).

Co-authored-by: sloane <sloane@revive.musterd>
Co-Authored-By: Claude Opus 5.5 <noreply@anthropic.com>
Claude-Session: https://claude.ai/code/session_01QX4vA5KS4DQyrZXvTQVSqj
</commit_message>
<xml_diff>
--- a/docs/demo/multiplayer-ai-2026-10-01/deck.pptx
+++ b/docs/demo/multiplayer-ai-2026-10-01/deck.pptx
@@ -4220,7 +4220,7 @@
                 <a:ea typeface="Arial" pitchFamily="34" charset="-122"/>
                 <a:cs typeface="Arial" pitchFamily="34" charset="-120"/>
               </a:rPr>
-              <a:t>A named member, from Claude Code, Codex, Cursor or OpenCode. People join from the CLI. musterd’s own harness is coming.</a:t>
+              <a:t>A named member on the roster. People join from the CLI.</a:t>
             </a:r>
             <a:endParaRPr lang="en-US" sz="1500" dirty="0"/>
           </a:p>
@@ -4791,6 +4791,84 @@
               <a:t>The builder submits. Another member accepts the outcome.</a:t>
             </a:r>
             <a:endParaRPr lang="en-US" sz="1500" dirty="0"/>
+          </a:p>
+        </p:txBody>
+      </p:sp>
+      <p:sp>
+        <p:nvSpPr>
+          <p:cNvPr id="24" name="Shape 22"/>
+          <p:cNvSpPr/>
+          <p:nvPr/>
+        </p:nvSpPr>
+        <p:spPr>
+          <a:xfrm>
+            <a:off x="640080" y="5349240"/>
+            <a:ext cx="10911535" cy="22860"/>
+          </a:xfrm>
+          <a:prstGeom prst="rect">
+            <a:avLst/>
+          </a:prstGeom>
+          <a:solidFill>
+            <a:srgbClr val="E4E4E7"/>
+          </a:solidFill>
+          <a:ln w="12700">
+            <a:solidFill>
+              <a:srgbClr val="E4E4E7"/>
+            </a:solidFill>
+            <a:prstDash val="solid"/>
+          </a:ln>
+        </p:spPr>
+      </p:sp>
+      <p:sp>
+        <p:nvSpPr>
+          <p:cNvPr id="25" name="Text 23"/>
+          <p:cNvSpPr txBox="1"/>
+          <p:nvPr/>
+        </p:nvSpPr>
+        <p:spPr>
+          <a:xfrm>
+            <a:off x="640080" y="5486400"/>
+            <a:ext cx="10911535" cy="548640"/>
+          </a:xfrm>
+          <a:prstGeom prst="rect">
+            <a:avLst/>
+          </a:prstGeom>
+          <a:noFill/>
+          <a:ln/>
+        </p:spPr>
+        <p:txBody>
+          <a:bodyPr wrap="square" lIns="0" tIns="0" rIns="0" bIns="0" rtlCol="0" anchor="ctr"/>
+          <a:lstStyle/>
+          <a:p>
+            <a:pPr indent="0" marL="0">
+              <a:buNone/>
+            </a:pPr>
+            <a:r>
+              <a:rPr lang="en-US" sz="2200" b="1" dirty="0">
+                <a:solidFill>
+                  <a:srgbClr val="18181B"/>
+                </a:solidFill>
+                <a:latin typeface="Arial" pitchFamily="34" charset="0"/>
+                <a:ea typeface="Arial" pitchFamily="34" charset="-122"/>
+                <a:cs typeface="Arial" pitchFamily="34" charset="-120"/>
+              </a:rPr>
+              <a:t>Bring your agents, from any harness.</a:t>
+            </a:r>
+            <a:pPr indent="0" marL="0">
+              <a:buNone/>
+            </a:pPr>
+            <a:r>
+              <a:rPr lang="en-US" sz="1500" dirty="0">
+                <a:solidFill>
+                  <a:srgbClr val="52525B"/>
+                </a:solidFill>
+                <a:latin typeface="Arial" pitchFamily="34" charset="0"/>
+                <a:ea typeface="Arial" pitchFamily="34" charset="-122"/>
+                <a:cs typeface="Arial" pitchFamily="34" charset="-120"/>
+              </a:rPr>
+              <a:t>   Fully supported today: Claude Code · Codex · Cursor · OpenCode. Coming: musterd’s own harness.</a:t>
+            </a:r>
+            <a:endParaRPr lang="en-US" sz="2200" dirty="0"/>
           </a:p>
         </p:txBody>
       </p:sp>

</xml_diff>

<commit_message>
docs(demo): close line and pptx questions slide drop the init command, musterd.io before portfolio
Co-authored-by: sloane <sloane@revive.musterd>
Co-Authored-By: Claude Opus 5.5 <noreply@anthropic.com>
Claude-Session: https://claude.ai/code/session_01B9BwJ1ThY3bMxBeo1ZuBdK
</commit_message>
<xml_diff>
--- a/docs/demo/multiplayer-ai-2026-10-01/deck.pptx
+++ b/docs/demo/multiplayer-ai-2026-10-01/deck.pptx
@@ -599,7 +599,7 @@
           <a:p>
             <a:r>
               <a:rPr lang="en-US" dirty="0"/>
-              <a:t>It's open source: npx @musterd/cli init. If you run more than one agent, try it with your team for two weeks, and I'll sit with you for the first hour. I build it live on Twitch every day. Thank you.</a:t>
+              <a:t>It's open source, at musterd.io. I build it live on Twitch every day. Thank you.</a:t>
             </a:r>
             <a:endParaRPr lang="en-US" dirty="0"/>
           </a:p>
@@ -2360,14 +2360,70 @@
       </p:sp>
       <p:sp>
         <p:nvSpPr>
-          <p:cNvPr id="4" name="Shape 2"/>
+          <p:cNvPr id="7" name="Text 5"/>
+          <p:cNvSpPr txBox="1"/>
+          <p:nvPr/>
+        </p:nvSpPr>
+        <p:spPr>
+          <a:xfrm>
+            <a:off x="640080" y="2468880"/>
+            <a:ext cx="5760720" cy="822960"/>
+          </a:xfrm>
+          <a:prstGeom prst="rect">
+            <a:avLst/>
+          </a:prstGeom>
+          <a:noFill/>
+          <a:ln/>
+        </p:spPr>
+        <p:txBody>
+          <a:bodyPr wrap="square" lIns="0" tIns="0" rIns="0" bIns="0" rtlCol="0" anchor="ctr"/>
+          <a:lstStyle/>
+          <a:p>
+            <a:pPr indent="0" marL="0">
+              <a:buNone/>
+            </a:pPr>
+            <a:r>
+              <a:rPr lang="en-US" sz="1700" b="1" dirty="0">
+                <a:solidFill>
+                  <a:srgbClr val="18181B"/>
+                </a:solidFill>
+                <a:latin typeface="Arial" pitchFamily="34" charset="0"/>
+                <a:ea typeface="Arial" pitchFamily="34" charset="-122"/>
+                <a:cs typeface="Arial" pitchFamily="34" charset="-120"/>
+              </a:rPr>
+              <a:t>Bring your agents, from any harness.</a:t>
+            </a:r>
+            <a:endParaRPr lang="en-US" sz="1700" dirty="0"/>
+          </a:p>
+          <a:p>
+            <a:pPr indent="0" marL="0">
+              <a:buNone/>
+            </a:pPr>
+            <a:r>
+              <a:rPr lang="en-US" sz="1400" dirty="0">
+                <a:solidFill>
+                  <a:srgbClr val="52525B"/>
+                </a:solidFill>
+                <a:latin typeface="Arial" pitchFamily="34" charset="0"/>
+                <a:ea typeface="Arial" pitchFamily="34" charset="-122"/>
+                <a:cs typeface="Arial" pitchFamily="34" charset="-120"/>
+              </a:rPr>
+              <a:t>Claude Code · Codex · Cursor · opencode · musterd harness (coming)</a:t>
+            </a:r>
+            <a:endParaRPr lang="en-US" sz="1700" dirty="0"/>
+          </a:p>
+        </p:txBody>
+      </p:sp>
+      <p:sp>
+        <p:nvSpPr>
+          <p:cNvPr id="8" name="Shape 6"/>
           <p:cNvSpPr/>
           <p:nvPr/>
         </p:nvSpPr>
         <p:spPr>
           <a:xfrm>
-            <a:off x="640080" y="2468880"/>
-            <a:ext cx="5760720" cy="914400"/>
+            <a:off x="6766560" y="2194560"/>
+            <a:ext cx="4754880" cy="914400"/>
           </a:xfrm>
           <a:prstGeom prst="roundRect">
             <a:avLst>
@@ -2387,14 +2443,41 @@
       </p:sp>
       <p:sp>
         <p:nvSpPr>
-          <p:cNvPr id="5" name="Text 3"/>
-          <p:cNvSpPr txBox="1"/>
-          <p:nvPr/>
-        </p:nvSpPr>
-        <p:spPr>
-          <a:xfrm>
-            <a:off x="914400" y="2468880"/>
-            <a:ext cx="5303520" cy="914400"/>
+          <p:cNvPr id="9" name="Shape 7"/>
+          <p:cNvSpPr/>
+          <p:nvPr/>
+        </p:nvSpPr>
+        <p:spPr>
+          <a:xfrm>
+            <a:off x="6949440" y="2395728"/>
+            <a:ext cx="512064" cy="512064"/>
+          </a:xfrm>
+          <a:prstGeom prst="roundRect">
+            <a:avLst>
+              <a:gd name="adj" fmla="val 17857"/>
+            </a:avLst>
+          </a:prstGeom>
+          <a:solidFill>
+            <a:srgbClr val="9146FF"/>
+          </a:solidFill>
+          <a:ln w="12700">
+            <a:solidFill>
+              <a:srgbClr val="9146FF"/>
+            </a:solidFill>
+            <a:prstDash val="solid"/>
+          </a:ln>
+        </p:spPr>
+      </p:sp>
+      <p:sp>
+        <p:nvSpPr>
+          <p:cNvPr id="10" name="Text 8"/>
+          <p:cNvSpPr txBox="1"/>
+          <p:nvPr/>
+        </p:nvSpPr>
+        <p:spPr>
+          <a:xfrm>
+            <a:off x="7635240" y="2304288"/>
+            <a:ext cx="3749040" cy="694944"/>
           </a:xfrm>
           <a:prstGeom prst="rect">
             <a:avLst/>
@@ -2410,60 +2493,24 @@
               <a:buNone/>
             </a:pPr>
             <a:r>
-              <a:rPr lang="en-US" sz="2800" b="1" dirty="0">
-                <a:solidFill>
-                  <a:srgbClr val="A1A1AA"/>
+              <a:rPr lang="en-US" sz="1700" b="1" dirty="0">
+                <a:solidFill>
+                  <a:srgbClr val="18181B"/>
                 </a:solidFill>
                 <a:latin typeface="Courier New" pitchFamily="34" charset="0"/>
                 <a:ea typeface="Courier New" pitchFamily="34" charset="-122"/>
                 <a:cs typeface="Courier New" pitchFamily="34" charset="-120"/>
               </a:rPr>
-              <a:t>$ </a:t>
-            </a:r>
-            <a:pPr indent="0" marL="0">
-              <a:buNone/>
-            </a:pPr>
-            <a:r>
-              <a:rPr lang="en-US" sz="2800" b="1" dirty="0">
-                <a:solidFill>
-                  <a:srgbClr val="18181B"/>
-                </a:solidFill>
-                <a:latin typeface="Courier New" pitchFamily="34" charset="0"/>
-                <a:ea typeface="Courier New" pitchFamily="34" charset="-122"/>
-                <a:cs typeface="Courier New" pitchFamily="34" charset="-120"/>
-              </a:rPr>
-              <a:t>npx @musterd/cli init</a:t>
-            </a:r>
-            <a:endParaRPr lang="en-US" sz="2800" dirty="0"/>
-          </a:p>
-        </p:txBody>
-      </p:sp>
-      <p:sp>
-        <p:nvSpPr>
-          <p:cNvPr id="6" name="Text 4"/>
-          <p:cNvSpPr txBox="1"/>
-          <p:nvPr/>
-        </p:nvSpPr>
-        <p:spPr>
-          <a:xfrm>
-            <a:off x="640080" y="3611880"/>
-            <a:ext cx="5760720" cy="1005840"/>
-          </a:xfrm>
-          <a:prstGeom prst="rect">
-            <a:avLst/>
-          </a:prstGeom>
-          <a:noFill/>
-          <a:ln/>
-        </p:spPr>
-        <p:txBody>
-          <a:bodyPr wrap="square" lIns="0" tIns="0" rIns="0" bIns="0" rtlCol="0" anchor="ctr"/>
-          <a:lstStyle/>
-          <a:p>
-            <a:pPr indent="0" marL="0">
-              <a:buNone/>
-            </a:pPr>
-            <a:r>
-              <a:rPr lang="en-US" sz="1700" dirty="0">
+              <a:t>twitch.tv/sandrise_ai</a:t>
+            </a:r>
+            <a:endParaRPr lang="en-US" sz="1700" dirty="0"/>
+          </a:p>
+          <a:p>
+            <a:pPr indent="0" marL="0">
+              <a:buNone/>
+            </a:pPr>
+            <a:r>
+              <a:rPr lang="en-US" sz="1200" dirty="0">
                 <a:solidFill>
                   <a:srgbClr val="52525B"/>
                 </a:solidFill>
@@ -2471,7 +2518,7 @@
                 <a:ea typeface="Arial" pitchFamily="34" charset="-122"/>
                 <a:cs typeface="Arial" pitchFamily="34" charset="-120"/>
               </a:rPr>
-              <a:t>Open source. If you run more than one agent, try it with your team for two weeks. I'll sit with you for the first hour.</a:t>
+              <a:t>musterd, built live every day</a:t>
             </a:r>
             <a:endParaRPr lang="en-US" sz="1700" dirty="0"/>
           </a:p>
@@ -2479,69 +2526,13 @@
       </p:sp>
       <p:sp>
         <p:nvSpPr>
-          <p:cNvPr id="7" name="Text 5"/>
-          <p:cNvSpPr txBox="1"/>
-          <p:nvPr/>
-        </p:nvSpPr>
-        <p:spPr>
-          <a:xfrm>
-            <a:off x="640080" y="4754880"/>
-            <a:ext cx="5760720" cy="822960"/>
-          </a:xfrm>
-          <a:prstGeom prst="rect">
-            <a:avLst/>
-          </a:prstGeom>
-          <a:noFill/>
-          <a:ln/>
-        </p:spPr>
-        <p:txBody>
-          <a:bodyPr wrap="square" lIns="0" tIns="0" rIns="0" bIns="0" rtlCol="0" anchor="ctr"/>
-          <a:lstStyle/>
-          <a:p>
-            <a:pPr indent="0" marL="0">
-              <a:buNone/>
-            </a:pPr>
-            <a:r>
-              <a:rPr lang="en-US" sz="1700" b="1" dirty="0">
-                <a:solidFill>
-                  <a:srgbClr val="18181B"/>
-                </a:solidFill>
-                <a:latin typeface="Arial" pitchFamily="34" charset="0"/>
-                <a:ea typeface="Arial" pitchFamily="34" charset="-122"/>
-                <a:cs typeface="Arial" pitchFamily="34" charset="-120"/>
-              </a:rPr>
-              <a:t>Bring your agents, from any harness.</a:t>
-            </a:r>
-            <a:endParaRPr lang="en-US" sz="1700" dirty="0"/>
-          </a:p>
-          <a:p>
-            <a:pPr indent="0" marL="0">
-              <a:buNone/>
-            </a:pPr>
-            <a:r>
-              <a:rPr lang="en-US" sz="1400" dirty="0">
-                <a:solidFill>
-                  <a:srgbClr val="52525B"/>
-                </a:solidFill>
-                <a:latin typeface="Arial" pitchFamily="34" charset="0"/>
-                <a:ea typeface="Arial" pitchFamily="34" charset="-122"/>
-                <a:cs typeface="Arial" pitchFamily="34" charset="-120"/>
-              </a:rPr>
-              <a:t>Claude Code · Codex · Cursor · opencode · musterd harness (coming)</a:t>
-            </a:r>
-            <a:endParaRPr lang="en-US" sz="1700" dirty="0"/>
-          </a:p>
-        </p:txBody>
-      </p:sp>
-      <p:sp>
-        <p:nvSpPr>
-          <p:cNvPr id="8" name="Shape 6"/>
+          <p:cNvPr id="11" name="Shape 9"/>
           <p:cNvSpPr/>
           <p:nvPr/>
         </p:nvSpPr>
         <p:spPr>
           <a:xfrm>
-            <a:off x="6766560" y="2194560"/>
+            <a:off x="6766560" y="4389120"/>
             <a:ext cx="4754880" cy="914400"/>
           </a:xfrm>
           <a:prstGeom prst="roundRect">
@@ -2562,13 +2553,13 @@
       </p:sp>
       <p:sp>
         <p:nvSpPr>
-          <p:cNvPr id="9" name="Shape 7"/>
+          <p:cNvPr id="12" name="Shape 10"/>
           <p:cNvSpPr/>
           <p:nvPr/>
         </p:nvSpPr>
         <p:spPr>
           <a:xfrm>
-            <a:off x="6949440" y="2395728"/>
+            <a:off x="6949440" y="4590288"/>
             <a:ext cx="512064" cy="512064"/>
           </a:xfrm>
           <a:prstGeom prst="roundRect">
@@ -2577,11 +2568,11 @@
             </a:avLst>
           </a:prstGeom>
           <a:solidFill>
-            <a:srgbClr val="9146FF"/>
+            <a:srgbClr val="7A5A06"/>
           </a:solidFill>
           <a:ln w="12700">
             <a:solidFill>
-              <a:srgbClr val="9146FF"/>
+              <a:srgbClr val="7A5A06"/>
             </a:solidFill>
             <a:prstDash val="solid"/>
           </a:ln>
@@ -2589,13 +2580,13 @@
       </p:sp>
       <p:sp>
         <p:nvSpPr>
-          <p:cNvPr id="10" name="Text 8"/>
-          <p:cNvSpPr txBox="1"/>
-          <p:nvPr/>
-        </p:nvSpPr>
-        <p:spPr>
-          <a:xfrm>
-            <a:off x="7635240" y="2304288"/>
+          <p:cNvPr id="13" name="Text 11"/>
+          <p:cNvSpPr txBox="1"/>
+          <p:nvPr/>
+        </p:nvSpPr>
+        <p:spPr>
+          <a:xfrm>
+            <a:off x="7635240" y="4498848"/>
             <a:ext cx="3749040" cy="694944"/>
           </a:xfrm>
           <a:prstGeom prst="rect">
@@ -2620,7 +2611,7 @@
                 <a:ea typeface="Courier New" pitchFamily="34" charset="-122"/>
                 <a:cs typeface="Courier New" pitchFamily="34" charset="-120"/>
               </a:rPr>
-              <a:t>twitch.tv/sandrise_ai</a:t>
+              <a:t>sandrise.io/nicksanders</a:t>
             </a:r>
             <a:endParaRPr lang="en-US" sz="1700" dirty="0"/>
           </a:p>
@@ -2637,7 +2628,7 @@
                 <a:ea typeface="Arial" pitchFamily="34" charset="-122"/>
                 <a:cs typeface="Arial" pitchFamily="34" charset="-120"/>
               </a:rPr>
-              <a:t>musterd, built live every day</a:t>
+              <a:t>Portfolio</a:t>
             </a:r>
             <a:endParaRPr lang="en-US" sz="1700" dirty="0"/>
           </a:p>
@@ -2645,7 +2636,7 @@
       </p:sp>
       <p:sp>
         <p:nvSpPr>
-          <p:cNvPr id="11" name="Shape 9"/>
+          <p:cNvPr id="14" name="Shape 12"/>
           <p:cNvSpPr/>
           <p:nvPr/>
         </p:nvSpPr>
@@ -2672,123 +2663,13 @@
       </p:sp>
       <p:sp>
         <p:nvSpPr>
-          <p:cNvPr id="12" name="Shape 10"/>
-          <p:cNvSpPr/>
-          <p:nvPr/>
-        </p:nvSpPr>
-        <p:spPr>
-          <a:xfrm>
-            <a:off x="6949440" y="3493008"/>
-            <a:ext cx="512064" cy="512064"/>
-          </a:xfrm>
-          <a:prstGeom prst="roundRect">
-            <a:avLst>
-              <a:gd name="adj" fmla="val 17857"/>
-            </a:avLst>
-          </a:prstGeom>
-          <a:solidFill>
-            <a:srgbClr val="7A5A06"/>
-          </a:solidFill>
-          <a:ln w="12700">
-            <a:solidFill>
-              <a:srgbClr val="7A5A06"/>
-            </a:solidFill>
-            <a:prstDash val="solid"/>
-          </a:ln>
-        </p:spPr>
-      </p:sp>
-      <p:sp>
-        <p:nvSpPr>
-          <p:cNvPr id="13" name="Text 11"/>
-          <p:cNvSpPr txBox="1"/>
-          <p:nvPr/>
-        </p:nvSpPr>
-        <p:spPr>
-          <a:xfrm>
-            <a:off x="7635240" y="3401568"/>
-            <a:ext cx="3749040" cy="694944"/>
-          </a:xfrm>
-          <a:prstGeom prst="rect">
-            <a:avLst/>
-          </a:prstGeom>
-          <a:noFill/>
-          <a:ln/>
-        </p:spPr>
-        <p:txBody>
-          <a:bodyPr wrap="square" lIns="0" tIns="0" rIns="0" bIns="0" rtlCol="0" anchor="ctr"/>
-          <a:lstStyle/>
-          <a:p>
-            <a:pPr indent="0" marL="0">
-              <a:buNone/>
-            </a:pPr>
-            <a:r>
-              <a:rPr lang="en-US" sz="1700" b="1" dirty="0">
-                <a:solidFill>
-                  <a:srgbClr val="18181B"/>
-                </a:solidFill>
-                <a:latin typeface="Courier New" pitchFamily="34" charset="0"/>
-                <a:ea typeface="Courier New" pitchFamily="34" charset="-122"/>
-                <a:cs typeface="Courier New" pitchFamily="34" charset="-120"/>
-              </a:rPr>
-              <a:t>sandrise.io/nicksanders</a:t>
-            </a:r>
-            <a:endParaRPr lang="en-US" sz="1700" dirty="0"/>
-          </a:p>
-          <a:p>
-            <a:pPr indent="0" marL="0">
-              <a:buNone/>
-            </a:pPr>
-            <a:r>
-              <a:rPr lang="en-US" sz="1200" dirty="0">
-                <a:solidFill>
-                  <a:srgbClr val="52525B"/>
-                </a:solidFill>
-                <a:latin typeface="Arial" pitchFamily="34" charset="0"/>
-                <a:ea typeface="Arial" pitchFamily="34" charset="-122"/>
-                <a:cs typeface="Arial" pitchFamily="34" charset="-120"/>
-              </a:rPr>
-              <a:t>Portfolio</a:t>
-            </a:r>
-            <a:endParaRPr lang="en-US" sz="1700" dirty="0"/>
-          </a:p>
-        </p:txBody>
-      </p:sp>
-      <p:sp>
-        <p:nvSpPr>
-          <p:cNvPr id="14" name="Shape 12"/>
-          <p:cNvSpPr/>
-          <p:nvPr/>
-        </p:nvSpPr>
-        <p:spPr>
-          <a:xfrm>
-            <a:off x="6766560" y="4389120"/>
-            <a:ext cx="4754880" cy="914400"/>
-          </a:xfrm>
-          <a:prstGeom prst="roundRect">
-            <a:avLst>
-              <a:gd name="adj" fmla="val 12000"/>
-            </a:avLst>
-          </a:prstGeom>
-          <a:solidFill>
-            <a:srgbClr val="FFFFFF"/>
-          </a:solidFill>
-          <a:ln w="9525">
-            <a:solidFill>
-              <a:srgbClr val="E4E4E7"/>
-            </a:solidFill>
-            <a:prstDash val="solid"/>
-          </a:ln>
-        </p:spPr>
-      </p:sp>
-      <p:sp>
-        <p:nvSpPr>
           <p:cNvPr id="15" name="Shape 13"/>
           <p:cNvSpPr/>
           <p:nvPr/>
         </p:nvSpPr>
         <p:spPr>
           <a:xfrm>
-            <a:off x="6949440" y="4590288"/>
+            <a:off x="6949440" y="3493008"/>
             <a:ext cx="512064" cy="512064"/>
           </a:xfrm>
           <a:prstGeom prst="roundRect">
@@ -2815,7 +2696,7 @@
         </p:nvSpPr>
         <p:spPr>
           <a:xfrm>
-            <a:off x="7635240" y="4498848"/>
+            <a:off x="7635240" y="3401568"/>
             <a:ext cx="3749040" cy="694944"/>
           </a:xfrm>
           <a:prstGeom prst="rect">

</xml_diff>

<commit_message>
fix(brand): the demo deck's PPTX cover carries the new mark, not the old chip (ADR 497)
The cover's chip was two shapes (a mustard roundRect + an "m" text box) exported
from the HTML deck, so #1998/#2002 — which refreshed deck.html's chip.svg
reference — left the .pptx showing the old gold square. Replaced both shapes with
a picture of the full mark (512px PNG from docs/design/assets/chip.svg) at the
same position and size. Only slide 1 had a chip; the three baked graphics carry
no logo. Rendered old-vs-new through Quick Look to confirm. Caught by big-body in
acceptance.

Refs ADR-497

Co-authored-by: miley <miley@revive.musterd>
Co-Authored-By: Claude Sonnet 5.5 <noreply@anthropic.com>
Claude-Session: https://claude.ai/code/session_01WBrTeQe8p2ecfu7ddwyMSB
</commit_message>
<xml_diff>
--- a/docs/demo/multiplayer-ai-2026-10-01/deck.pptx
+++ b/docs/demo/multiplayer-ai-2026-10-01/deck.pptx
@@ -1676,72 +1676,30 @@
           <a:chExt cx="0" cy="0"/>
         </a:xfrm>
       </p:grpSpPr>
-      <p:sp>
-        <p:nvSpPr>
-          <p:cNvPr id="2" name="Shape 0"/>
-          <p:cNvSpPr/>
-          <p:nvPr/>
-        </p:nvSpPr>
+      <p:pic>
+        <p:nvPicPr>
+          <p:cNvPr id="2" name="musterd mark" descr="musterd mark"/>
+          <p:cNvPicPr>
+            <a:picLocks noChangeAspect="1"/>
+          </p:cNvPicPr>
+          <p:nvPr/>
+        </p:nvPicPr>
+        <p:blipFill>
+          <a:blip r:embed="rId3"/>
+          <a:stretch>
+            <a:fillRect/>
+          </a:stretch>
+        </p:blipFill>
         <p:spPr>
           <a:xfrm>
             <a:off x="640080" y="640080"/>
             <a:ext cx="502920" cy="502920"/>
           </a:xfrm>
-          <a:prstGeom prst="roundRect">
-            <a:avLst>
-              <a:gd name="adj" fmla="val 18182"/>
-            </a:avLst>
-          </a:prstGeom>
-          <a:solidFill>
-            <a:srgbClr val="E1AD01"/>
-          </a:solidFill>
-          <a:ln w="12700">
-            <a:solidFill>
-              <a:srgbClr val="E1AD01"/>
-            </a:solidFill>
-            <a:prstDash val="solid"/>
-          </a:ln>
-        </p:spPr>
-      </p:sp>
-      <p:sp>
-        <p:nvSpPr>
-          <p:cNvPr id="3" name="Text 1"/>
-          <p:cNvSpPr txBox="1"/>
-          <p:nvPr/>
-        </p:nvSpPr>
-        <p:spPr>
-          <a:xfrm>
-            <a:off x="640080" y="640080"/>
-            <a:ext cx="502920" cy="502920"/>
-          </a:xfrm>
-          <a:prstGeom prst="rect">
-            <a:avLst/>
-          </a:prstGeom>
-          <a:noFill/>
-          <a:ln/>
-        </p:spPr>
-        <p:txBody>
-          <a:bodyPr wrap="square" lIns="0" tIns="0" rIns="0" bIns="0" rtlCol="0" anchor="ctr"/>
-          <a:lstStyle/>
-          <a:p>
-            <a:pPr algn="ctr" indent="0" marL="0">
-              <a:buNone/>
-            </a:pPr>
-            <a:r>
-              <a:rPr lang="en-US" sz="2600" b="1" dirty="0">
-                <a:solidFill>
-                  <a:srgbClr val="18181B"/>
-                </a:solidFill>
-                <a:latin typeface="Courier New" pitchFamily="34" charset="0"/>
-                <a:ea typeface="Courier New" pitchFamily="34" charset="-122"/>
-                <a:cs typeface="Courier New" pitchFamily="34" charset="-120"/>
-              </a:rPr>
-              <a:t>m</a:t>
-            </a:r>
-            <a:endParaRPr lang="en-US" sz="2600" dirty="0"/>
-          </a:p>
-        </p:txBody>
-      </p:sp>
+          <a:prstGeom prst="rect">
+            <a:avLst/>
+          </a:prstGeom>
+        </p:spPr>
+      </p:pic>
       <p:sp>
         <p:nvSpPr>
           <p:cNvPr id="4" name="Text 2"/>

</xml_diff>

<commit_message>
fix(brand): the demo deck's PPTX cover carries the new mark (ADR 497, lane 2 follow-up) (#2013)
big-body declined lane 2: the rendered deck.pptx cover still showed the
old gold chip. The chip was two shapes (roundRect + 'm' text box) in
slide1.xml; replaced with a picture of the full mark at the same
position/size (new ppt/media/image-1-mark.png, rId3). Only slide 1 had a
chip. Verified old-vs-new via Quick Look. Binary-only change besides the
rels/xml inside the zip. Lane 01M3ZHCW2Q8Z2DM0P4YY12MB0N. sloane has an
active lane on docs/demo/** (01M3TGXA9WSYTKK422K80VX8JM) — this touches
only the slide-1 chip; I've told them.

🤖 Generated with [Claude Code](https://claude.com/claude-code)

https://claude.ai/code/session_01WBrTeQe8p2ecfu7ddwyMSB

Co-authored-by: miley (musterd seat) <miley@revive.musterd>
Co-authored-by: Claude Sonnet 5.5 <noreply@anthropic.com>
</commit_message>
<xml_diff>
--- a/docs/demo/multiplayer-ai-2026-10-01/deck.pptx
+++ b/docs/demo/multiplayer-ai-2026-10-01/deck.pptx
@@ -1676,72 +1676,30 @@
           <a:chExt cx="0" cy="0"/>
         </a:xfrm>
       </p:grpSpPr>
-      <p:sp>
-        <p:nvSpPr>
-          <p:cNvPr id="2" name="Shape 0"/>
-          <p:cNvSpPr/>
-          <p:nvPr/>
-        </p:nvSpPr>
+      <p:pic>
+        <p:nvPicPr>
+          <p:cNvPr id="2" name="musterd mark" descr="musterd mark"/>
+          <p:cNvPicPr>
+            <a:picLocks noChangeAspect="1"/>
+          </p:cNvPicPr>
+          <p:nvPr/>
+        </p:nvPicPr>
+        <p:blipFill>
+          <a:blip r:embed="rId3"/>
+          <a:stretch>
+            <a:fillRect/>
+          </a:stretch>
+        </p:blipFill>
         <p:spPr>
           <a:xfrm>
             <a:off x="640080" y="640080"/>
             <a:ext cx="502920" cy="502920"/>
           </a:xfrm>
-          <a:prstGeom prst="roundRect">
-            <a:avLst>
-              <a:gd name="adj" fmla="val 18182"/>
-            </a:avLst>
-          </a:prstGeom>
-          <a:solidFill>
-            <a:srgbClr val="E1AD01"/>
-          </a:solidFill>
-          <a:ln w="12700">
-            <a:solidFill>
-              <a:srgbClr val="E1AD01"/>
-            </a:solidFill>
-            <a:prstDash val="solid"/>
-          </a:ln>
-        </p:spPr>
-      </p:sp>
-      <p:sp>
-        <p:nvSpPr>
-          <p:cNvPr id="3" name="Text 1"/>
-          <p:cNvSpPr txBox="1"/>
-          <p:nvPr/>
-        </p:nvSpPr>
-        <p:spPr>
-          <a:xfrm>
-            <a:off x="640080" y="640080"/>
-            <a:ext cx="502920" cy="502920"/>
-          </a:xfrm>
-          <a:prstGeom prst="rect">
-            <a:avLst/>
-          </a:prstGeom>
-          <a:noFill/>
-          <a:ln/>
-        </p:spPr>
-        <p:txBody>
-          <a:bodyPr wrap="square" lIns="0" tIns="0" rIns="0" bIns="0" rtlCol="0" anchor="ctr"/>
-          <a:lstStyle/>
-          <a:p>
-            <a:pPr algn="ctr" indent="0" marL="0">
-              <a:buNone/>
-            </a:pPr>
-            <a:r>
-              <a:rPr lang="en-US" sz="2600" b="1" dirty="0">
-                <a:solidFill>
-                  <a:srgbClr val="18181B"/>
-                </a:solidFill>
-                <a:latin typeface="Courier New" pitchFamily="34" charset="0"/>
-                <a:ea typeface="Courier New" pitchFamily="34" charset="-122"/>
-                <a:cs typeface="Courier New" pitchFamily="34" charset="-120"/>
-              </a:rPr>
-              <a:t>m</a:t>
-            </a:r>
-            <a:endParaRPr lang="en-US" sz="2600" dirty="0"/>
-          </a:p>
-        </p:txBody>
-      </p:sp>
+          <a:prstGeom prst="rect">
+            <a:avLst/>
+          </a:prstGeom>
+        </p:spPr>
+      </p:pic>
       <p:sp>
         <p:nvSpPr>
           <p:cNvPr id="4" name="Text 2"/>

</xml_diff>

<commit_message>
docs(demo): product-communications sweep of the Multiplayer AI deck + §8
Honesty: the thesis footer no longer mixes units (1% of tokens vs 37% of
code); the Co-Gym line compares the ablation's own pair (70% vs 30%), not
86% against 30%; the notes say a day and a half, matching the slide.
Clarity: 'cross-family if available' becomes 'from another model family
when one is live'; the handoff card says the author is the last person to
see the work misses the brief. Voice: sentence-case thesis head, 'Seats'
(glossary). Private preview: the thank-you slide drops the GitHub link and
marks the musterd harness 'not yet'. Applied to deck.html, deck.pptx
(slides 3, 10) and the §8 script. Lane 01M3TGXA9WSYTKK422K80VX8JM.

Co-authored-by: sloane <sloane@revive.musterd>
Co-Authored-By: Claude Opus 5.5 <noreply@anthropic.com>
</commit_message>
<xml_diff>
--- a/docs/demo/multiplayer-ai-2026-10-01/deck.pptx
+++ b/docs/demo/multiplayer-ai-2026-10-01/deck.pptx
@@ -2366,7 +2366,7 @@
                 <a:ea typeface="Arial" pitchFamily="34" charset="-122"/>
                 <a:cs typeface="Arial" pitchFamily="34" charset="-120"/>
               </a:rPr>
-              <a:t>Claude Code · Codex · Cursor · opencode · musterd harness (coming)</a:t>
+              <a:t>Claude Code · Codex · Cursor · opencode · musterd harness (not yet)</a:t>
             </a:r>
             <a:endParaRPr lang="en-US" sz="1700" dirty="0"/>
           </a:p>
@@ -2696,7 +2696,7 @@
                 <a:ea typeface="Arial" pitchFamily="34" charset="-122"/>
                 <a:cs typeface="Arial" pitchFamily="34" charset="-120"/>
               </a:rPr>
-              <a:t>github.com/SandRiseStudio/musterd</a:t>
+              <a:t>in private preview</a:t>
             </a:r>
             <a:endParaRPr lang="en-US" sz="1700" dirty="0"/>
           </a:p>
@@ -4110,7 +4110,7 @@
                 <a:ea typeface="Arial" pitchFamily="34" charset="-122"/>
                 <a:cs typeface="Arial" pitchFamily="34" charset="-120"/>
               </a:rPr>
-              <a:t>Another member checks the outcome, cross-family if available</a:t>
+              <a:t>Another member checks the outcome, from another model family when one is live</a:t>
             </a:r>
             <a:endParaRPr lang="en-US" sz="1500" dirty="0"/>
           </a:p>

</xml_diff>

<commit_message>
docs(demo): comms sweep of the Multiplayer AI deck + §8 (#2043)
Lane 01M3TGXA9WSYTKK422K80VX8JM (resumed by nick 2026-10-03). Five-sweep
pass per the product-communications skill. Fixes: unit-mixed thesis
footer, mismatched Co-Gym comparison (86 vs 30 → 70 vs 30), 'two days'
vs 'a day and a half', jargon 'cross-family if available', the confusing
'author is the one person sure' line, title-case head, 'Agent Seats' →
'Seats', GitHub link + 'coming' on the thank-you slide (repo is
private). deck.html slides 2 and 11 rendered and viewed; deck.pptx text
patched on slides 3 and 10 (zip validated; no local renderer).

🤖 Generated with [Claude Code](https://claude.com/claude-code)

Co-authored-by: sloane (musterd seat) <sloane@revive.musterd>
Co-authored-by: Claude Opus 5.5 <noreply@anthropic.com>
</commit_message>
<xml_diff>
--- a/docs/demo/multiplayer-ai-2026-10-01/deck.pptx
+++ b/docs/demo/multiplayer-ai-2026-10-01/deck.pptx
@@ -2366,7 +2366,7 @@
                 <a:ea typeface="Arial" pitchFamily="34" charset="-122"/>
                 <a:cs typeface="Arial" pitchFamily="34" charset="-120"/>
               </a:rPr>
-              <a:t>Claude Code · Codex · Cursor · opencode · musterd harness (coming)</a:t>
+              <a:t>Claude Code · Codex · Cursor · opencode · musterd harness (not yet)</a:t>
             </a:r>
             <a:endParaRPr lang="en-US" sz="1700" dirty="0"/>
           </a:p>
@@ -2696,7 +2696,7 @@
                 <a:ea typeface="Arial" pitchFamily="34" charset="-122"/>
                 <a:cs typeface="Arial" pitchFamily="34" charset="-120"/>
               </a:rPr>
-              <a:t>github.com/SandRiseStudio/musterd</a:t>
+              <a:t>in private preview</a:t>
             </a:r>
             <a:endParaRPr lang="en-US" sz="1700" dirty="0"/>
           </a:p>
@@ -4110,7 +4110,7 @@
                 <a:ea typeface="Arial" pitchFamily="34" charset="-122"/>
                 <a:cs typeface="Arial" pitchFamily="34" charset="-120"/>
               </a:rPr>
-              <a:t>Another member checks the outcome, cross-family if available</a:t>
+              <a:t>Another member checks the outcome, from another model family when one is live</a:t>
             </a:r>
             <a:endParaRPr lang="en-US" sz="1500" dirty="0"/>
           </a:p>

</xml_diff>